<commit_message>
Add Policy Intelligence via RAG and multi-regulation compliance slide to pitch deck
</commit_message>
<xml_diff>
--- a/assets/deck/ZKD_Concierge_Codestreet_2026.pptx
+++ b/assets/deck/ZKD_Concierge_Codestreet_2026.pptx
@@ -14,6 +14,7 @@
     <p:sldId id="262" r:id="rId13"/>
     <p:sldId id="263" r:id="rId14"/>
     <p:sldId id="264" r:id="rId15"/>
+    <p:sldId id="265" r:id="rId16"/>
   </p:sldIdLst>
   <p:sldSz cx="12191695" cy="6858000" type="screen4x3"/>
   <p:notesSz cx="6858000" cy="9144000"/>
@@ -3227,6 +3228,298 @@
 </p:sld>
 </file>
 
+<file path=ppt/slides/slide10.xml><?xml version="1.0" encoding="utf-8"?>
+<p:sld xmlns:a="http://schemas.openxmlformats.org/drawingml/2006/main" xmlns:p="http://schemas.openxmlformats.org/presentationml/2006/main" xmlns:r="http://schemas.openxmlformats.org/officeDocument/2006/relationships">
+  <p:cSld>
+    <p:spTree>
+      <p:nvGrpSpPr>
+        <p:cNvPr id="1" name=""/>
+        <p:cNvGrpSpPr/>
+        <p:nvPr/>
+      </p:nvGrpSpPr>
+      <p:grpSpPr/>
+      <p:sp>
+        <p:nvSpPr>
+          <p:cNvPr id="2" name="TextBox 1"/>
+          <p:cNvSpPr txBox="1"/>
+          <p:nvPr/>
+        </p:nvSpPr>
+        <p:spPr>
+          <a:xfrm>
+            <a:off x="731520" y="457200"/>
+            <a:ext cx="10698480" cy="365760"/>
+          </a:xfrm>
+          <a:prstGeom prst="rect">
+            <a:avLst/>
+          </a:prstGeom>
+          <a:noFill/>
+        </p:spPr>
+        <p:txBody>
+          <a:bodyPr wrap="square">
+            <a:spAutoFit/>
+          </a:bodyPr>
+          <a:lstStyle/>
+          <a:p>
+            <a:pPr>
+              <a:defRPr sz="1000" b="1">
+                <a:solidFill>
+                  <a:srgbClr val="006FCF"/>
+                </a:solidFill>
+              </a:defRPr>
+            </a:pPr>
+            <a:r>
+              <a:t>ZKD CONCIERGE · AMERICAN EXPRESS / CODESTREET 2026</a:t>
+            </a:r>
+          </a:p>
+        </p:txBody>
+      </p:sp>
+      <p:sp>
+        <p:nvSpPr>
+          <p:cNvPr id="3" name="TextBox 2"/>
+          <p:cNvSpPr txBox="1"/>
+          <p:nvPr/>
+        </p:nvSpPr>
+        <p:spPr>
+          <a:xfrm>
+            <a:off x="731520" y="731520"/>
+            <a:ext cx="10698480" cy="731520"/>
+          </a:xfrm>
+          <a:prstGeom prst="rect">
+            <a:avLst/>
+          </a:prstGeom>
+          <a:noFill/>
+        </p:spPr>
+        <p:txBody>
+          <a:bodyPr wrap="square">
+            <a:spAutoFit/>
+          </a:bodyPr>
+          <a:lstStyle/>
+          <a:p>
+            <a:pPr>
+              <a:defRPr sz="2600" b="1">
+                <a:solidFill>
+                  <a:srgbClr val="0F172A"/>
+                </a:solidFill>
+              </a:defRPr>
+            </a:pPr>
+            <a:r>
+              <a:t>Honest Limitations, Roadmap &amp; Conclusion</a:t>
+            </a:r>
+          </a:p>
+        </p:txBody>
+      </p:sp>
+      <p:sp>
+        <p:nvSpPr>
+          <p:cNvPr id="4" name="Rounded Rectangle 3"/>
+          <p:cNvSpPr/>
+          <p:nvPr/>
+        </p:nvSpPr>
+        <p:spPr>
+          <a:xfrm>
+            <a:off x="731520" y="1645920"/>
+            <a:ext cx="5120640" cy="4389120"/>
+          </a:xfrm>
+          <a:prstGeom prst="roundRect">
+            <a:avLst/>
+          </a:prstGeom>
+          <a:solidFill>
+            <a:srgbClr val="F8FAFC"/>
+          </a:solidFill>
+          <a:ln>
+            <a:solidFill>
+              <a:srgbClr val="E2E8F0"/>
+            </a:solidFill>
+          </a:ln>
+        </p:spPr>
+        <p:style>
+          <a:lnRef idx="1">
+            <a:schemeClr val="accent1"/>
+          </a:lnRef>
+          <a:fillRef idx="3">
+            <a:schemeClr val="accent1"/>
+          </a:fillRef>
+          <a:effectRef idx="2">
+            <a:schemeClr val="accent1"/>
+          </a:effectRef>
+          <a:fontRef idx="minor">
+            <a:schemeClr val="lt1"/>
+          </a:fontRef>
+        </p:style>
+        <p:txBody>
+          <a:bodyPr rtlCol="0" anchor="ctr" wrap="square"/>
+          <a:lstStyle/>
+          <a:p>
+            <a:pPr algn="ctr">
+              <a:spcAft>
+                <a:spcPts val="1000"/>
+              </a:spcAft>
+              <a:defRPr sz="1600" b="1">
+                <a:solidFill>
+                  <a:srgbClr val="B91C1C"/>
+                </a:solidFill>
+              </a:defRPr>
+            </a:pPr>
+            <a:r>
+              <a:t>Honest Limitations</a:t>
+            </a:r>
+          </a:p>
+          <a:p>
+            <a:pPr>
+              <a:spcAft>
+                <a:spcPts val="600"/>
+              </a:spcAft>
+              <a:defRPr sz="1200">
+                <a:solidFill>
+                  <a:srgbClr val="64748B"/>
+                </a:solidFill>
+              </a:defRPr>
+            </a:pPr>
+            <a:r>
+              <a:t>• No Indian domestic training data yet: risk model cold-starts to population base rate until retrain loop runs.</a:t>
+            </a:r>
+          </a:p>
+          <a:p>
+            <a:pPr>
+              <a:spcAft>
+                <a:spcPts val="600"/>
+              </a:spcAft>
+              <a:defRPr sz="1200">
+                <a:solidFill>
+                  <a:srgbClr val="64748B"/>
+                </a:solidFill>
+              </a:defRPr>
+            </a:pPr>
+            <a:r>
+              <a:t>• Payment is mocked (vPayment contract test; no live payment gateway).</a:t>
+            </a:r>
+          </a:p>
+          <a:p>
+            <a:pPr>
+              <a:spcAft>
+                <a:spcPts val="600"/>
+              </a:spcAft>
+              <a:defRPr sz="1200">
+                <a:solidFill>
+                  <a:srgbClr val="64748B"/>
+                </a:solidFill>
+              </a:defRPr>
+            </a:pPr>
+            <a:r>
+              <a:t>• Pull-only API rate limit constraints on flight status feeds.</a:t>
+            </a:r>
+          </a:p>
+        </p:txBody>
+      </p:sp>
+      <p:sp>
+        <p:nvSpPr>
+          <p:cNvPr id="5" name="Rounded Rectangle 4"/>
+          <p:cNvSpPr/>
+          <p:nvPr/>
+        </p:nvSpPr>
+        <p:spPr>
+          <a:xfrm>
+            <a:off x="6217920" y="1645920"/>
+            <a:ext cx="5212080" cy="4389120"/>
+          </a:xfrm>
+          <a:prstGeom prst="roundRect">
+            <a:avLst/>
+          </a:prstGeom>
+          <a:solidFill>
+            <a:srgbClr val="F8FAFC"/>
+          </a:solidFill>
+          <a:ln>
+            <a:solidFill>
+              <a:srgbClr val="E2E8F0"/>
+            </a:solidFill>
+          </a:ln>
+        </p:spPr>
+        <p:style>
+          <a:lnRef idx="1">
+            <a:schemeClr val="accent1"/>
+          </a:lnRef>
+          <a:fillRef idx="3">
+            <a:schemeClr val="accent1"/>
+          </a:fillRef>
+          <a:effectRef idx="2">
+            <a:schemeClr val="accent1"/>
+          </a:effectRef>
+          <a:fontRef idx="minor">
+            <a:schemeClr val="lt1"/>
+          </a:fontRef>
+        </p:style>
+        <p:txBody>
+          <a:bodyPr rtlCol="0" anchor="ctr" wrap="square"/>
+          <a:lstStyle/>
+          <a:p>
+            <a:pPr algn="ctr">
+              <a:spcAft>
+                <a:spcPts val="1000"/>
+              </a:spcAft>
+              <a:defRPr sz="1600" b="1">
+                <a:solidFill>
+                  <a:srgbClr val="006FCF"/>
+                </a:solidFill>
+              </a:defRPr>
+            </a:pPr>
+            <a:r>
+              <a:t>Roadmap &amp; Closing</a:t>
+            </a:r>
+          </a:p>
+          <a:p>
+            <a:pPr>
+              <a:spcAft>
+                <a:spcPts val="600"/>
+              </a:spcAft>
+              <a:defRPr sz="1200">
+                <a:solidFill>
+                  <a:srgbClr val="64748B"/>
+                </a:solidFill>
+              </a:defRPr>
+            </a:pPr>
+            <a:r>
+              <a:t>• Production Rollout: Live webhook subscriptions &amp; automated event loggers.</a:t>
+            </a:r>
+          </a:p>
+          <a:p>
+            <a:pPr>
+              <a:spcAft>
+                <a:spcPts val="600"/>
+              </a:spcAft>
+              <a:defRPr sz="1200">
+                <a:solidFill>
+                  <a:srgbClr val="64748B"/>
+                </a:solidFill>
+              </a:defRPr>
+            </a:pPr>
+            <a:r>
+              <a:t>• Full integration of default-deny policy engine (`server/policy/`).</a:t>
+            </a:r>
+          </a:p>
+          <a:p>
+            <a:pPr>
+              <a:spcAft>
+                <a:spcPts val="600"/>
+              </a:spcAft>
+              <a:defRPr sz="1200">
+                <a:solidFill>
+                  <a:srgbClr val="64748B"/>
+                </a:solidFill>
+              </a:defRPr>
+            </a:pPr>
+            <a:r>
+              <a:t>• Elevating American Express cardmember trust through uncompromising proactive service.</a:t>
+            </a:r>
+          </a:p>
+        </p:txBody>
+      </p:sp>
+    </p:spTree>
+  </p:cSld>
+  <p:clrMapOvr>
+    <a:masterClrMapping/>
+  </p:clrMapOvr>
+</p:sld>
+</file>
+
 <file path=ppt/slides/slide2.xml><?xml version="1.0" encoding="utf-8"?>
 <p:sld xmlns:a="http://schemas.openxmlformats.org/drawingml/2006/main" xmlns:p="http://schemas.openxmlformats.org/presentationml/2006/main" xmlns:r="http://schemas.openxmlformats.org/officeDocument/2006/relationships">
   <p:cSld>
@@ -4734,7 +5027,7 @@
               </a:defRPr>
             </a:pPr>
             <a:r>
-              <a:t>System Architecture &amp; Multi-Device State Sync</a:t>
+              <a:t>Policy Intelligence via RAG &amp; Multi-Regulation Compliance</a:t>
             </a:r>
           </a:p>
         </p:txBody>
@@ -4791,7 +5084,7 @@
               </a:defRPr>
             </a:pPr>
             <a:r>
-              <a:t>Server-Authoritative Simulation Engine</a:t>
+              <a:t>Multi-Regulation Scope (Beyond DGCA)</a:t>
             </a:r>
           </a:p>
           <a:p>
@@ -4806,7 +5099,7 @@
               </a:defRPr>
             </a:pPr>
             <a:r>
-              <a:t>• Module-level simulation engine (`server/engine/simulation.ts`) runs the whole lifecycle.</a:t>
+              <a:t>• Not just DGCA (Indian domestic aviation), but international passenger rights frameworks: **EU261** and **UK261**.</a:t>
             </a:r>
           </a:p>
           <a:p>
@@ -4821,7 +5114,7 @@
               </a:defRPr>
             </a:pPr>
             <a:r>
-              <a:t>• Real `setTimeout`/`setInterval` chains resolve on schedule whether devices watch or not.</a:t>
+              <a:t>• Carrier-specific contract clauses &amp; operating terms (e.g. British Airways vs Emirates compensation entitlements).</a:t>
             </a:r>
           </a:p>
           <a:p>
@@ -4836,7 +5129,7 @@
               </a:defRPr>
             </a:pPr>
             <a:r>
-              <a:t>• Single source of truth: shared state ledger (`server/decisionLedger.ts`).</a:t>
+              <a:t>• Amex Card Product Benefit terms (`server/myca.ts`): card-holder cabin ceilings, lounge access, and per-transaction rules.</a:t>
             </a:r>
           </a:p>
           <a:p>
@@ -4851,7 +5144,7 @@
               </a:defRPr>
             </a:pPr>
             <a:r>
-              <a:t>• Zero GPU on critical path: 95% of time is network wait on supplier APIs.</a:t>
+              <a:t>• Jurisdiction routing: automatically detects which regulatory framework governs the PNR.</a:t>
             </a:r>
           </a:p>
         </p:txBody>
@@ -4908,7 +5201,7 @@
               </a:defRPr>
             </a:pPr>
             <a:r>
-              <a:t>Multi-Device Sync &amp; Identity Switchers</a:t>
+              <a:t>RAG &amp; Default-Deny Policy Engine</a:t>
             </a:r>
           </a:p>
           <a:p>
@@ -4923,7 +5216,7 @@
               </a:defRPr>
             </a:pPr>
             <a:r>
-              <a:t>• Stateless clients: Next.js web app (`zkd-app/`) &amp; Expo React Native Android app (`zkd-android/`).</a:t>
+              <a:t>• **RAG Ingestion:** Automatically vectorizes and indexes complex aviation regulations, carrier fare rules, and card terms.</a:t>
             </a:r>
           </a:p>
           <a:p>
@@ -4938,7 +5231,7 @@
               </a:defRPr>
             </a:pPr>
             <a:r>
-              <a:t>• Clean polling architecture (`GET /api/passengers/[id]/schedule`).</a:t>
+              <a:t>• **Context Retrieval:** Dynamically queries relevant clauses when a disruption occurs for a specific PNR and airline.</a:t>
             </a:r>
           </a:p>
           <a:p>
@@ -4953,7 +5246,7 @@
               </a:defRPr>
             </a:pPr>
             <a:r>
-              <a:t>• Identity switcher (`?as=p-priya` vs `?as=p-arjun`): open two tabs side-by-side to prove independent tenant state.</a:t>
+              <a:t>• **OPA Policy Gate (`server/policy/`):** Default-deny rule engine. Every option is evaluated against retrieved policy clauses in-process (&lt;1ms).</a:t>
             </a:r>
           </a:p>
           <a:p>
@@ -4968,7 +5261,7 @@
               </a:defRPr>
             </a:pPr>
             <a:r>
-              <a:t>• Actions on mobile/web instantly converge via shared backend.</a:t>
+              <a:t>• Incomplete policy inputs trigger default-deny — nothing executes without explicit allow.</a:t>
             </a:r>
           </a:p>
         </p:txBody>
@@ -4982,6 +5275,328 @@
 </file>
 
 <file path=ppt/slides/slide7.xml><?xml version="1.0" encoding="utf-8"?>
+<p:sld xmlns:a="http://schemas.openxmlformats.org/drawingml/2006/main" xmlns:p="http://schemas.openxmlformats.org/presentationml/2006/main" xmlns:r="http://schemas.openxmlformats.org/officeDocument/2006/relationships">
+  <p:cSld>
+    <p:spTree>
+      <p:nvGrpSpPr>
+        <p:cNvPr id="1" name=""/>
+        <p:cNvGrpSpPr/>
+        <p:nvPr/>
+      </p:nvGrpSpPr>
+      <p:grpSpPr/>
+      <p:sp>
+        <p:nvSpPr>
+          <p:cNvPr id="2" name="TextBox 1"/>
+          <p:cNvSpPr txBox="1"/>
+          <p:nvPr/>
+        </p:nvSpPr>
+        <p:spPr>
+          <a:xfrm>
+            <a:off x="731520" y="457200"/>
+            <a:ext cx="10698480" cy="365760"/>
+          </a:xfrm>
+          <a:prstGeom prst="rect">
+            <a:avLst/>
+          </a:prstGeom>
+          <a:noFill/>
+        </p:spPr>
+        <p:txBody>
+          <a:bodyPr wrap="square">
+            <a:spAutoFit/>
+          </a:bodyPr>
+          <a:lstStyle/>
+          <a:p>
+            <a:pPr>
+              <a:defRPr sz="1000" b="1">
+                <a:solidFill>
+                  <a:srgbClr val="006FCF"/>
+                </a:solidFill>
+              </a:defRPr>
+            </a:pPr>
+            <a:r>
+              <a:t>ZKD CONCIERGE · AMERICAN EXPRESS / CODESTREET 2026</a:t>
+            </a:r>
+          </a:p>
+        </p:txBody>
+      </p:sp>
+      <p:sp>
+        <p:nvSpPr>
+          <p:cNvPr id="3" name="TextBox 2"/>
+          <p:cNvSpPr txBox="1"/>
+          <p:nvPr/>
+        </p:nvSpPr>
+        <p:spPr>
+          <a:xfrm>
+            <a:off x="731520" y="731520"/>
+            <a:ext cx="10698480" cy="731520"/>
+          </a:xfrm>
+          <a:prstGeom prst="rect">
+            <a:avLst/>
+          </a:prstGeom>
+          <a:noFill/>
+        </p:spPr>
+        <p:txBody>
+          <a:bodyPr wrap="square">
+            <a:spAutoFit/>
+          </a:bodyPr>
+          <a:lstStyle/>
+          <a:p>
+            <a:pPr>
+              <a:defRPr sz="2600" b="1">
+                <a:solidFill>
+                  <a:srgbClr val="0F172A"/>
+                </a:solidFill>
+              </a:defRPr>
+            </a:pPr>
+            <a:r>
+              <a:t>System Architecture &amp; Multi-Device State Sync</a:t>
+            </a:r>
+          </a:p>
+        </p:txBody>
+      </p:sp>
+      <p:sp>
+        <p:nvSpPr>
+          <p:cNvPr id="4" name="Rounded Rectangle 3"/>
+          <p:cNvSpPr/>
+          <p:nvPr/>
+        </p:nvSpPr>
+        <p:spPr>
+          <a:xfrm>
+            <a:off x="731520" y="1645920"/>
+            <a:ext cx="5120640" cy="4389120"/>
+          </a:xfrm>
+          <a:prstGeom prst="roundRect">
+            <a:avLst/>
+          </a:prstGeom>
+          <a:solidFill>
+            <a:srgbClr val="F8FAFC"/>
+          </a:solidFill>
+          <a:ln>
+            <a:solidFill>
+              <a:srgbClr val="E2E8F0"/>
+            </a:solidFill>
+          </a:ln>
+        </p:spPr>
+        <p:style>
+          <a:lnRef idx="1">
+            <a:schemeClr val="accent1"/>
+          </a:lnRef>
+          <a:fillRef idx="3">
+            <a:schemeClr val="accent1"/>
+          </a:fillRef>
+          <a:effectRef idx="2">
+            <a:schemeClr val="accent1"/>
+          </a:effectRef>
+          <a:fontRef idx="minor">
+            <a:schemeClr val="lt1"/>
+          </a:fontRef>
+        </p:style>
+        <p:txBody>
+          <a:bodyPr rtlCol="0" anchor="ctr" wrap="square"/>
+          <a:lstStyle/>
+          <a:p>
+            <a:pPr algn="ctr">
+              <a:spcAft>
+                <a:spcPts val="1000"/>
+              </a:spcAft>
+              <a:defRPr sz="1600" b="1">
+                <a:solidFill>
+                  <a:srgbClr val="0F172A"/>
+                </a:solidFill>
+              </a:defRPr>
+            </a:pPr>
+            <a:r>
+              <a:t>Server-Authoritative Simulation Engine</a:t>
+            </a:r>
+          </a:p>
+          <a:p>
+            <a:pPr>
+              <a:spcAft>
+                <a:spcPts val="600"/>
+              </a:spcAft>
+              <a:defRPr sz="1200">
+                <a:solidFill>
+                  <a:srgbClr val="64748B"/>
+                </a:solidFill>
+              </a:defRPr>
+            </a:pPr>
+            <a:r>
+              <a:t>• Module-level simulation engine (`server/engine/simulation.ts`) runs the whole lifecycle.</a:t>
+            </a:r>
+          </a:p>
+          <a:p>
+            <a:pPr>
+              <a:spcAft>
+                <a:spcPts val="600"/>
+              </a:spcAft>
+              <a:defRPr sz="1200">
+                <a:solidFill>
+                  <a:srgbClr val="64748B"/>
+                </a:solidFill>
+              </a:defRPr>
+            </a:pPr>
+            <a:r>
+              <a:t>• Real `setTimeout`/`setInterval` chains resolve on schedule whether devices watch or not.</a:t>
+            </a:r>
+          </a:p>
+          <a:p>
+            <a:pPr>
+              <a:spcAft>
+                <a:spcPts val="600"/>
+              </a:spcAft>
+              <a:defRPr sz="1200">
+                <a:solidFill>
+                  <a:srgbClr val="64748B"/>
+                </a:solidFill>
+              </a:defRPr>
+            </a:pPr>
+            <a:r>
+              <a:t>• Single source of truth: shared state ledger (`server/decisionLedger.ts`).</a:t>
+            </a:r>
+          </a:p>
+          <a:p>
+            <a:pPr>
+              <a:spcAft>
+                <a:spcPts val="600"/>
+              </a:spcAft>
+              <a:defRPr sz="1200">
+                <a:solidFill>
+                  <a:srgbClr val="64748B"/>
+                </a:solidFill>
+              </a:defRPr>
+            </a:pPr>
+            <a:r>
+              <a:t>• Zero GPU on critical path: 95% of time is network wait on supplier APIs.</a:t>
+            </a:r>
+          </a:p>
+        </p:txBody>
+      </p:sp>
+      <p:sp>
+        <p:nvSpPr>
+          <p:cNvPr id="5" name="Rounded Rectangle 4"/>
+          <p:cNvSpPr/>
+          <p:nvPr/>
+        </p:nvSpPr>
+        <p:spPr>
+          <a:xfrm>
+            <a:off x="6217920" y="1645920"/>
+            <a:ext cx="5212080" cy="4389120"/>
+          </a:xfrm>
+          <a:prstGeom prst="roundRect">
+            <a:avLst/>
+          </a:prstGeom>
+          <a:solidFill>
+            <a:srgbClr val="F8FAFC"/>
+          </a:solidFill>
+          <a:ln>
+            <a:solidFill>
+              <a:srgbClr val="E2E8F0"/>
+            </a:solidFill>
+          </a:ln>
+        </p:spPr>
+        <p:style>
+          <a:lnRef idx="1">
+            <a:schemeClr val="accent1"/>
+          </a:lnRef>
+          <a:fillRef idx="3">
+            <a:schemeClr val="accent1"/>
+          </a:fillRef>
+          <a:effectRef idx="2">
+            <a:schemeClr val="accent1"/>
+          </a:effectRef>
+          <a:fontRef idx="minor">
+            <a:schemeClr val="lt1"/>
+          </a:fontRef>
+        </p:style>
+        <p:txBody>
+          <a:bodyPr rtlCol="0" anchor="ctr" wrap="square"/>
+          <a:lstStyle/>
+          <a:p>
+            <a:pPr algn="ctr">
+              <a:spcAft>
+                <a:spcPts val="1000"/>
+              </a:spcAft>
+              <a:defRPr sz="1600" b="1">
+                <a:solidFill>
+                  <a:srgbClr val="006FCF"/>
+                </a:solidFill>
+              </a:defRPr>
+            </a:pPr>
+            <a:r>
+              <a:t>Multi-Device Sync &amp; Identity Switchers</a:t>
+            </a:r>
+          </a:p>
+          <a:p>
+            <a:pPr>
+              <a:spcAft>
+                <a:spcPts val="600"/>
+              </a:spcAft>
+              <a:defRPr sz="1200">
+                <a:solidFill>
+                  <a:srgbClr val="64748B"/>
+                </a:solidFill>
+              </a:defRPr>
+            </a:pPr>
+            <a:r>
+              <a:t>• Stateless clients: Next.js web app (`zkd-app/`) &amp; Expo React Native Android app (`zkd-android/`).</a:t>
+            </a:r>
+          </a:p>
+          <a:p>
+            <a:pPr>
+              <a:spcAft>
+                <a:spcPts val="600"/>
+              </a:spcAft>
+              <a:defRPr sz="1200">
+                <a:solidFill>
+                  <a:srgbClr val="64748B"/>
+                </a:solidFill>
+              </a:defRPr>
+            </a:pPr>
+            <a:r>
+              <a:t>• Clean polling architecture (`GET /api/passengers/[id]/schedule`).</a:t>
+            </a:r>
+          </a:p>
+          <a:p>
+            <a:pPr>
+              <a:spcAft>
+                <a:spcPts val="600"/>
+              </a:spcAft>
+              <a:defRPr sz="1200">
+                <a:solidFill>
+                  <a:srgbClr val="64748B"/>
+                </a:solidFill>
+              </a:defRPr>
+            </a:pPr>
+            <a:r>
+              <a:t>• Identity switcher (`?as=p-priya` vs `?as=p-arjun`): open two tabs side-by-side to prove independent tenant state.</a:t>
+            </a:r>
+          </a:p>
+          <a:p>
+            <a:pPr>
+              <a:spcAft>
+                <a:spcPts val="600"/>
+              </a:spcAft>
+              <a:defRPr sz="1200">
+                <a:solidFill>
+                  <a:srgbClr val="64748B"/>
+                </a:solidFill>
+              </a:defRPr>
+            </a:pPr>
+            <a:r>
+              <a:t>• Actions on mobile/web instantly converge via shared backend.</a:t>
+            </a:r>
+          </a:p>
+        </p:txBody>
+      </p:sp>
+    </p:spTree>
+  </p:cSld>
+  <p:clrMapOvr>
+    <a:masterClrMapping/>
+  </p:clrMapOvr>
+</p:sld>
+</file>
+
+<file path=ppt/slides/slide8.xml><?xml version="1.0" encoding="utf-8"?>
 <p:sld xmlns:a="http://schemas.openxmlformats.org/drawingml/2006/main" xmlns:p="http://schemas.openxmlformats.org/presentationml/2006/main" xmlns:r="http://schemas.openxmlformats.org/officeDocument/2006/relationships">
   <p:cSld>
     <p:spTree>
@@ -5567,7 +6182,7 @@
 </p:sld>
 </file>
 
-<file path=ppt/slides/slide8.xml><?xml version="1.0" encoding="utf-8"?>
+<file path=ppt/slides/slide9.xml><?xml version="1.0" encoding="utf-8"?>
 <p:sld xmlns:a="http://schemas.openxmlformats.org/drawingml/2006/main" xmlns:p="http://schemas.openxmlformats.org/presentationml/2006/main" xmlns:r="http://schemas.openxmlformats.org/officeDocument/2006/relationships">
   <p:cSld>
     <p:spTree>
@@ -5847,298 +6462,6 @@
             </a:pPr>
             <a:r>
               <a:t>• Safety rests entirely on consent gates and notification ladders—never on a probability score.</a:t>
-            </a:r>
-          </a:p>
-        </p:txBody>
-      </p:sp>
-    </p:spTree>
-  </p:cSld>
-  <p:clrMapOvr>
-    <a:masterClrMapping/>
-  </p:clrMapOvr>
-</p:sld>
-</file>
-
-<file path=ppt/slides/slide9.xml><?xml version="1.0" encoding="utf-8"?>
-<p:sld xmlns:a="http://schemas.openxmlformats.org/drawingml/2006/main" xmlns:p="http://schemas.openxmlformats.org/presentationml/2006/main" xmlns:r="http://schemas.openxmlformats.org/officeDocument/2006/relationships">
-  <p:cSld>
-    <p:spTree>
-      <p:nvGrpSpPr>
-        <p:cNvPr id="1" name=""/>
-        <p:cNvGrpSpPr/>
-        <p:nvPr/>
-      </p:nvGrpSpPr>
-      <p:grpSpPr/>
-      <p:sp>
-        <p:nvSpPr>
-          <p:cNvPr id="2" name="TextBox 1"/>
-          <p:cNvSpPr txBox="1"/>
-          <p:nvPr/>
-        </p:nvSpPr>
-        <p:spPr>
-          <a:xfrm>
-            <a:off x="731520" y="457200"/>
-            <a:ext cx="10698480" cy="365760"/>
-          </a:xfrm>
-          <a:prstGeom prst="rect">
-            <a:avLst/>
-          </a:prstGeom>
-          <a:noFill/>
-        </p:spPr>
-        <p:txBody>
-          <a:bodyPr wrap="square">
-            <a:spAutoFit/>
-          </a:bodyPr>
-          <a:lstStyle/>
-          <a:p>
-            <a:pPr>
-              <a:defRPr sz="1000" b="1">
-                <a:solidFill>
-                  <a:srgbClr val="006FCF"/>
-                </a:solidFill>
-              </a:defRPr>
-            </a:pPr>
-            <a:r>
-              <a:t>ZKD CONCIERGE · AMERICAN EXPRESS / CODESTREET 2026</a:t>
-            </a:r>
-          </a:p>
-        </p:txBody>
-      </p:sp>
-      <p:sp>
-        <p:nvSpPr>
-          <p:cNvPr id="3" name="TextBox 2"/>
-          <p:cNvSpPr txBox="1"/>
-          <p:nvPr/>
-        </p:nvSpPr>
-        <p:spPr>
-          <a:xfrm>
-            <a:off x="731520" y="731520"/>
-            <a:ext cx="10698480" cy="731520"/>
-          </a:xfrm>
-          <a:prstGeom prst="rect">
-            <a:avLst/>
-          </a:prstGeom>
-          <a:noFill/>
-        </p:spPr>
-        <p:txBody>
-          <a:bodyPr wrap="square">
-            <a:spAutoFit/>
-          </a:bodyPr>
-          <a:lstStyle/>
-          <a:p>
-            <a:pPr>
-              <a:defRPr sz="2600" b="1">
-                <a:solidFill>
-                  <a:srgbClr val="0F172A"/>
-                </a:solidFill>
-              </a:defRPr>
-            </a:pPr>
-            <a:r>
-              <a:t>Honest Limitations, Roadmap &amp; Conclusion</a:t>
-            </a:r>
-          </a:p>
-        </p:txBody>
-      </p:sp>
-      <p:sp>
-        <p:nvSpPr>
-          <p:cNvPr id="4" name="Rounded Rectangle 3"/>
-          <p:cNvSpPr/>
-          <p:nvPr/>
-        </p:nvSpPr>
-        <p:spPr>
-          <a:xfrm>
-            <a:off x="731520" y="1645920"/>
-            <a:ext cx="5120640" cy="4389120"/>
-          </a:xfrm>
-          <a:prstGeom prst="roundRect">
-            <a:avLst/>
-          </a:prstGeom>
-          <a:solidFill>
-            <a:srgbClr val="F8FAFC"/>
-          </a:solidFill>
-          <a:ln>
-            <a:solidFill>
-              <a:srgbClr val="E2E8F0"/>
-            </a:solidFill>
-          </a:ln>
-        </p:spPr>
-        <p:style>
-          <a:lnRef idx="1">
-            <a:schemeClr val="accent1"/>
-          </a:lnRef>
-          <a:fillRef idx="3">
-            <a:schemeClr val="accent1"/>
-          </a:fillRef>
-          <a:effectRef idx="2">
-            <a:schemeClr val="accent1"/>
-          </a:effectRef>
-          <a:fontRef idx="minor">
-            <a:schemeClr val="lt1"/>
-          </a:fontRef>
-        </p:style>
-        <p:txBody>
-          <a:bodyPr rtlCol="0" anchor="ctr" wrap="square"/>
-          <a:lstStyle/>
-          <a:p>
-            <a:pPr algn="ctr">
-              <a:spcAft>
-                <a:spcPts val="1000"/>
-              </a:spcAft>
-              <a:defRPr sz="1600" b="1">
-                <a:solidFill>
-                  <a:srgbClr val="B91C1C"/>
-                </a:solidFill>
-              </a:defRPr>
-            </a:pPr>
-            <a:r>
-              <a:t>Honest Limitations</a:t>
-            </a:r>
-          </a:p>
-          <a:p>
-            <a:pPr>
-              <a:spcAft>
-                <a:spcPts val="600"/>
-              </a:spcAft>
-              <a:defRPr sz="1200">
-                <a:solidFill>
-                  <a:srgbClr val="64748B"/>
-                </a:solidFill>
-              </a:defRPr>
-            </a:pPr>
-            <a:r>
-              <a:t>• No Indian domestic training data yet: risk model cold-starts to population base rate until retrain loop runs.</a:t>
-            </a:r>
-          </a:p>
-          <a:p>
-            <a:pPr>
-              <a:spcAft>
-                <a:spcPts val="600"/>
-              </a:spcAft>
-              <a:defRPr sz="1200">
-                <a:solidFill>
-                  <a:srgbClr val="64748B"/>
-                </a:solidFill>
-              </a:defRPr>
-            </a:pPr>
-            <a:r>
-              <a:t>• Payment is mocked (vPayment contract test; no live payment gateway).</a:t>
-            </a:r>
-          </a:p>
-          <a:p>
-            <a:pPr>
-              <a:spcAft>
-                <a:spcPts val="600"/>
-              </a:spcAft>
-              <a:defRPr sz="1200">
-                <a:solidFill>
-                  <a:srgbClr val="64748B"/>
-                </a:solidFill>
-              </a:defRPr>
-            </a:pPr>
-            <a:r>
-              <a:t>• Pull-only API rate limit constraints on flight status feeds.</a:t>
-            </a:r>
-          </a:p>
-        </p:txBody>
-      </p:sp>
-      <p:sp>
-        <p:nvSpPr>
-          <p:cNvPr id="5" name="Rounded Rectangle 4"/>
-          <p:cNvSpPr/>
-          <p:nvPr/>
-        </p:nvSpPr>
-        <p:spPr>
-          <a:xfrm>
-            <a:off x="6217920" y="1645920"/>
-            <a:ext cx="5212080" cy="4389120"/>
-          </a:xfrm>
-          <a:prstGeom prst="roundRect">
-            <a:avLst/>
-          </a:prstGeom>
-          <a:solidFill>
-            <a:srgbClr val="F8FAFC"/>
-          </a:solidFill>
-          <a:ln>
-            <a:solidFill>
-              <a:srgbClr val="E2E8F0"/>
-            </a:solidFill>
-          </a:ln>
-        </p:spPr>
-        <p:style>
-          <a:lnRef idx="1">
-            <a:schemeClr val="accent1"/>
-          </a:lnRef>
-          <a:fillRef idx="3">
-            <a:schemeClr val="accent1"/>
-          </a:fillRef>
-          <a:effectRef idx="2">
-            <a:schemeClr val="accent1"/>
-          </a:effectRef>
-          <a:fontRef idx="minor">
-            <a:schemeClr val="lt1"/>
-          </a:fontRef>
-        </p:style>
-        <p:txBody>
-          <a:bodyPr rtlCol="0" anchor="ctr" wrap="square"/>
-          <a:lstStyle/>
-          <a:p>
-            <a:pPr algn="ctr">
-              <a:spcAft>
-                <a:spcPts val="1000"/>
-              </a:spcAft>
-              <a:defRPr sz="1600" b="1">
-                <a:solidFill>
-                  <a:srgbClr val="006FCF"/>
-                </a:solidFill>
-              </a:defRPr>
-            </a:pPr>
-            <a:r>
-              <a:t>Roadmap &amp; Closing</a:t>
-            </a:r>
-          </a:p>
-          <a:p>
-            <a:pPr>
-              <a:spcAft>
-                <a:spcPts val="600"/>
-              </a:spcAft>
-              <a:defRPr sz="1200">
-                <a:solidFill>
-                  <a:srgbClr val="64748B"/>
-                </a:solidFill>
-              </a:defRPr>
-            </a:pPr>
-            <a:r>
-              <a:t>• Production Rollout: Live webhook subscriptions &amp; automated event loggers.</a:t>
-            </a:r>
-          </a:p>
-          <a:p>
-            <a:pPr>
-              <a:spcAft>
-                <a:spcPts val="600"/>
-              </a:spcAft>
-              <a:defRPr sz="1200">
-                <a:solidFill>
-                  <a:srgbClr val="64748B"/>
-                </a:solidFill>
-              </a:defRPr>
-            </a:pPr>
-            <a:r>
-              <a:t>• Full integration of default-deny policy engine (`server/policy/`).</a:t>
-            </a:r>
-          </a:p>
-          <a:p>
-            <a:pPr>
-              <a:spcAft>
-                <a:spcPts val="600"/>
-              </a:spcAft>
-              <a:defRPr sz="1200">
-                <a:solidFill>
-                  <a:srgbClr val="64748B"/>
-                </a:solidFill>
-              </a:defRPr>
-            </a:pPr>
-            <a:r>
-              <a:t>• Elevating American Express cardmember trust through uncompromising proactive service.</a:t>
             </a:r>
           </a:p>
         </p:txBody>

</xml_diff>